<commit_message>
Esclarece a transição de retorno no slide de estados (28)
A seta tracejada Devolvida → Encaminhada agora encosta na caixa de
destino, ganha rótulo inline ('reencaminhar?') e anotação explicativa
ao lado de Devolvida.

Co-Authored-By: Claude Fable 5 <noreply@anthropic.com>
Claude-Session: https://claude.ai/code/session_017GrziW5UYuREHfRcnVVMio
</commit_message>
<xml_diff>
--- a/workshops/workshop-historias-usuario-documentacao.pptx
+++ b/workshops/workshop-historias-usuario-documentacao.pptx
@@ -25969,7 +25969,7 @@
         <p:spPr>
           <a:xfrm>
             <a:off x="4956048" y="3849624"/>
-            <a:ext cx="-1188720" cy="-1188720"/>
+            <a:ext cx="-1207008" cy="-1252728"/>
           </a:xfrm>
           <a:prstGeom prst="line">
             <a:avLst/>
@@ -25992,24 +25992,24 @@
         </p:nvSpPr>
         <p:spPr>
           <a:xfrm>
-            <a:off x="685800" y="3977640"/>
-            <a:ext cx="4206240" cy="594360"/>
-          </a:xfrm>
-          <a:prstGeom prst="rect">
-            <a:avLst/>
-          </a:prstGeom>
-          <a:noFill/>
-          <a:ln/>
-        </p:spPr>
-        <p:txBody>
-          <a:bodyPr wrap="square" lIns="0" tIns="0" rIns="0" bIns="0" rtlCol="0" anchor="ctr"/>
-          <a:lstStyle/>
-          <a:p>
-            <a:pPr indent="0" marL="0">
-              <a:buNone/>
-            </a:pPr>
-            <a:r>
-              <a:rPr lang="en-US" sz="1050" i="1" dirty="0">
+            <a:off x="2651760" y="3017520"/>
+            <a:ext cx="1600200" cy="256032"/>
+          </a:xfrm>
+          <a:prstGeom prst="rect">
+            <a:avLst/>
+          </a:prstGeom>
+          <a:noFill/>
+          <a:ln/>
+        </p:spPr>
+        <p:txBody>
+          <a:bodyPr wrap="square" lIns="0" tIns="0" rIns="0" bIns="0" rtlCol="0" anchor="ctr"/>
+          <a:lstStyle/>
+          <a:p>
+            <a:pPr algn="r" indent="0" marL="0">
+              <a:buNone/>
+            </a:pPr>
+            <a:r>
+              <a:rPr lang="en-US" sz="1000" b="1" i="1" dirty="0">
                 <a:solidFill>
                   <a:srgbClr val="B2492F"/>
                 </a:solidFill>
@@ -26017,15 +26017,57 @@
                 <a:ea typeface="Calibri" pitchFamily="34" charset="-122"/>
                 <a:cs typeface="Calibri" pitchFamily="34" charset="-120"/>
               </a:rPr>
-              <a:t>⚠ reencaminhamento: permitido? com limite? — não especificado no caso real</a:t>
-            </a:r>
-            <a:endParaRPr lang="en-US" sz="1050" dirty="0"/>
+              <a:t>reencaminhar?</a:t>
+            </a:r>
+            <a:endParaRPr lang="en-US" sz="1000" dirty="0"/>
           </a:p>
         </p:txBody>
       </p:sp>
       <p:sp>
         <p:nvSpPr>
           <p:cNvPr id="25" name="Text 23"/>
+          <p:cNvSpPr/>
+          <p:nvPr/>
+        </p:nvSpPr>
+        <p:spPr>
+          <a:xfrm>
+            <a:off x="7086600" y="3566160"/>
+            <a:ext cx="4434840" cy="868680"/>
+          </a:xfrm>
+          <a:prstGeom prst="rect">
+            <a:avLst/>
+          </a:prstGeom>
+          <a:noFill/>
+          <a:ln/>
+        </p:spPr>
+        <p:txBody>
+          <a:bodyPr wrap="square" lIns="0" tIns="0" rIns="0" bIns="0" rtlCol="0" anchor="ctr"/>
+          <a:lstStyle/>
+          <a:p>
+            <a:pPr indent="0" marL="0">
+              <a:lnSpc>
+                <a:spcPct val="104000"/>
+              </a:lnSpc>
+              <a:buNone/>
+            </a:pPr>
+            <a:r>
+              <a:rPr lang="en-US" sz="1000" i="1" dirty="0">
+                <a:solidFill>
+                  <a:srgbClr val="B2492F"/>
+                </a:solidFill>
+                <a:latin typeface="Calibri" pitchFamily="34" charset="0"/>
+                <a:ea typeface="Calibri" pitchFamily="34" charset="-122"/>
+                <a:cs typeface="Calibri" pitchFamily="34" charset="-120"/>
+              </a:rPr>
+              <a:t>⚠ E a volta? A seta tracejada (devolvida → encaminhada) existe no processo, mas o caso real não diz se o reencaminhamento é permitido, nem com que limite.</a:t>
+            </a:r>
+            <a:endParaRPr lang="en-US" sz="1000" dirty="0"/>
+          </a:p>
+        </p:txBody>
+      </p:sp>
+      <p:sp>
+        <p:nvSpPr>
+          <p:cNvPr id="26" name="Text 24"/>
           <p:cNvSpPr/>
           <p:nvPr/>
         </p:nvSpPr>
@@ -26064,7 +26106,7 @@
       </p:sp>
       <p:sp>
         <p:nvSpPr>
-          <p:cNvPr id="26" name="Shape 24"/>
+          <p:cNvPr id="27" name="Shape 25"/>
           <p:cNvSpPr/>
           <p:nvPr/>
         </p:nvSpPr>
@@ -26086,7 +26128,7 @@
       </p:sp>
       <p:sp>
         <p:nvSpPr>
-          <p:cNvPr id="27" name="Text 25"/>
+          <p:cNvPr id="28" name="Text 26"/>
           <p:cNvSpPr/>
           <p:nvPr/>
         </p:nvSpPr>

</xml_diff>

<commit_message>
Corrige conectores bidirecionais do slide de rastreabilidade (29)
Substitui os pares de setas empilhadas (a inferior renderizava sem
ponta) por uma única seta de duas pontas entre os elos da cadeia.

Co-Authored-By: Claude Fable 5 <noreply@anthropic.com>
Claude-Session: https://claude.ai/code/session_017GrziW5UYuREHfRcnVVMio
</commit_message>
<xml_diff>
--- a/workshops/workshop-historias-usuario-documentacao.pptx
+++ b/workshops/workshop-historias-usuario-documentacao.pptx
@@ -26510,7 +26510,7 @@
         </p:nvSpPr>
         <p:spPr>
           <a:xfrm>
-            <a:off x="3136392" y="2331720"/>
+            <a:off x="3136392" y="2404872"/>
             <a:ext cx="365760" cy="0"/>
           </a:xfrm>
           <a:prstGeom prst="line">
@@ -26522,6 +26522,7 @@
               <a:srgbClr val="C77F1A"/>
             </a:solidFill>
             <a:prstDash val="solid"/>
+            <a:headEnd type="triangle"/>
             <a:tailEnd type="triangle"/>
           </a:ln>
         </p:spPr>
@@ -26529,30 +26530,6 @@
       <p:sp>
         <p:nvSpPr>
           <p:cNvPr id="12" name="Shape 9"/>
-          <p:cNvSpPr/>
-          <p:nvPr/>
-        </p:nvSpPr>
-        <p:spPr>
-          <a:xfrm>
-            <a:off x="3502152" y="2487168"/>
-            <a:ext cx="-365760" cy="0"/>
-          </a:xfrm>
-          <a:prstGeom prst="line">
-            <a:avLst/>
-          </a:prstGeom>
-          <a:noFill/>
-          <a:ln w="27940">
-            <a:solidFill>
-              <a:srgbClr val="C77F1A"/>
-            </a:solidFill>
-            <a:prstDash val="solid"/>
-            <a:tailEnd type="triangle"/>
-          </a:ln>
-        </p:spPr>
-      </p:sp>
-      <p:sp>
-        <p:nvSpPr>
-          <p:cNvPr id="13" name="Shape 10"/>
           <p:cNvSpPr/>
           <p:nvPr/>
         </p:nvSpPr>
@@ -26579,7 +26556,7 @@
       </p:sp>
       <p:sp>
         <p:nvSpPr>
-          <p:cNvPr id="14" name="Shape 11"/>
+          <p:cNvPr id="13" name="Shape 10"/>
           <p:cNvSpPr/>
           <p:nvPr/>
         </p:nvSpPr>
@@ -26599,7 +26576,7 @@
       </p:sp>
       <p:pic>
         <p:nvPicPr>
-          <p:cNvPr id="15" name="Image 1" descr="/tmp/claude-0/-home-user-doc-template-engine/198c21fb-8b4a-5b3c-a787-7fafcb963965/scratchpad/workshop/icons/file-white.png">    </p:cNvPr>
+          <p:cNvPr id="14" name="Image 1" descr="/tmp/claude-0/-home-user-doc-template-engine/198c21fb-8b4a-5b3c-a787-7fafcb963965/scratchpad/workshop/icons/file-white.png">    </p:cNvPr>
           <p:cNvPicPr>
             <a:picLocks noChangeAspect="1"/>
           </p:cNvPicPr>
@@ -26623,7 +26600,7 @@
       </p:pic>
       <p:sp>
         <p:nvSpPr>
-          <p:cNvPr id="16" name="Text 12"/>
+          <p:cNvPr id="15" name="Text 11"/>
           <p:cNvSpPr/>
           <p:nvPr/>
         </p:nvSpPr>
@@ -26662,7 +26639,7 @@
       </p:sp>
       <p:sp>
         <p:nvSpPr>
-          <p:cNvPr id="17" name="Text 13"/>
+          <p:cNvPr id="16" name="Text 12"/>
           <p:cNvSpPr/>
           <p:nvPr/>
         </p:nvSpPr>
@@ -26701,13 +26678,13 @@
       </p:sp>
       <p:sp>
         <p:nvSpPr>
-          <p:cNvPr id="18" name="Shape 14"/>
-          <p:cNvSpPr/>
-          <p:nvPr/>
-        </p:nvSpPr>
-        <p:spPr>
-          <a:xfrm>
-            <a:off x="6062472" y="2331720"/>
+          <p:cNvPr id="17" name="Shape 13"/>
+          <p:cNvSpPr/>
+          <p:nvPr/>
+        </p:nvSpPr>
+        <p:spPr>
+          <a:xfrm>
+            <a:off x="6062472" y="2404872"/>
             <a:ext cx="365760" cy="0"/>
           </a:xfrm>
           <a:prstGeom prst="line">
@@ -26719,37 +26696,14 @@
               <a:srgbClr val="C77F1A"/>
             </a:solidFill>
             <a:prstDash val="solid"/>
+            <a:headEnd type="triangle"/>
             <a:tailEnd type="triangle"/>
           </a:ln>
         </p:spPr>
       </p:sp>
       <p:sp>
         <p:nvSpPr>
-          <p:cNvPr id="19" name="Shape 15"/>
-          <p:cNvSpPr/>
-          <p:nvPr/>
-        </p:nvSpPr>
-        <p:spPr>
-          <a:xfrm>
-            <a:off x="6428232" y="2487168"/>
-            <a:ext cx="-365760" cy="0"/>
-          </a:xfrm>
-          <a:prstGeom prst="line">
-            <a:avLst/>
-          </a:prstGeom>
-          <a:noFill/>
-          <a:ln w="27940">
-            <a:solidFill>
-              <a:srgbClr val="C77F1A"/>
-            </a:solidFill>
-            <a:prstDash val="solid"/>
-            <a:tailEnd type="triangle"/>
-          </a:ln>
-        </p:spPr>
-      </p:sp>
-      <p:sp>
-        <p:nvSpPr>
-          <p:cNvPr id="20" name="Shape 16"/>
+          <p:cNvPr id="18" name="Shape 14"/>
           <p:cNvSpPr/>
           <p:nvPr/>
         </p:nvSpPr>
@@ -26776,7 +26730,7 @@
       </p:sp>
       <p:sp>
         <p:nvSpPr>
-          <p:cNvPr id="21" name="Shape 17"/>
+          <p:cNvPr id="19" name="Shape 15"/>
           <p:cNvSpPr/>
           <p:nvPr/>
         </p:nvSpPr>
@@ -26796,7 +26750,7 @@
       </p:sp>
       <p:pic>
         <p:nvPicPr>
-          <p:cNvPr id="22" name="Image 2" descr="/tmp/claude-0/-home-user-doc-template-engine/198c21fb-8b4a-5b3c-a787-7fafcb963965/scratchpad/workshop/icons/check-white.png">    </p:cNvPr>
+          <p:cNvPr id="20" name="Image 2" descr="/tmp/claude-0/-home-user-doc-template-engine/198c21fb-8b4a-5b3c-a787-7fafcb963965/scratchpad/workshop/icons/check-white.png">    </p:cNvPr>
           <p:cNvPicPr>
             <a:picLocks noChangeAspect="1"/>
           </p:cNvPicPr>
@@ -26820,7 +26774,7 @@
       </p:pic>
       <p:sp>
         <p:nvSpPr>
-          <p:cNvPr id="23" name="Text 18"/>
+          <p:cNvPr id="21" name="Text 16"/>
           <p:cNvSpPr/>
           <p:nvPr/>
         </p:nvSpPr>
@@ -26859,7 +26813,7 @@
       </p:sp>
       <p:sp>
         <p:nvSpPr>
-          <p:cNvPr id="24" name="Text 19"/>
+          <p:cNvPr id="22" name="Text 17"/>
           <p:cNvSpPr/>
           <p:nvPr/>
         </p:nvSpPr>
@@ -26898,13 +26852,13 @@
       </p:sp>
       <p:sp>
         <p:nvSpPr>
-          <p:cNvPr id="25" name="Shape 20"/>
-          <p:cNvSpPr/>
-          <p:nvPr/>
-        </p:nvSpPr>
-        <p:spPr>
-          <a:xfrm>
-            <a:off x="8988552" y="2331720"/>
+          <p:cNvPr id="23" name="Shape 18"/>
+          <p:cNvSpPr/>
+          <p:nvPr/>
+        </p:nvSpPr>
+        <p:spPr>
+          <a:xfrm>
+            <a:off x="8988552" y="2404872"/>
             <a:ext cx="365760" cy="0"/>
           </a:xfrm>
           <a:prstGeom prst="line">
@@ -26916,37 +26870,14 @@
               <a:srgbClr val="C77F1A"/>
             </a:solidFill>
             <a:prstDash val="solid"/>
+            <a:headEnd type="triangle"/>
             <a:tailEnd type="triangle"/>
           </a:ln>
         </p:spPr>
       </p:sp>
       <p:sp>
         <p:nvSpPr>
-          <p:cNvPr id="26" name="Shape 21"/>
-          <p:cNvSpPr/>
-          <p:nvPr/>
-        </p:nvSpPr>
-        <p:spPr>
-          <a:xfrm>
-            <a:off x="9354312" y="2487168"/>
-            <a:ext cx="-365760" cy="0"/>
-          </a:xfrm>
-          <a:prstGeom prst="line">
-            <a:avLst/>
-          </a:prstGeom>
-          <a:noFill/>
-          <a:ln w="27940">
-            <a:solidFill>
-              <a:srgbClr val="C77F1A"/>
-            </a:solidFill>
-            <a:prstDash val="solid"/>
-            <a:tailEnd type="triangle"/>
-          </a:ln>
-        </p:spPr>
-      </p:sp>
-      <p:sp>
-        <p:nvSpPr>
-          <p:cNvPr id="27" name="Shape 22"/>
+          <p:cNvPr id="24" name="Shape 19"/>
           <p:cNvSpPr/>
           <p:nvPr/>
         </p:nvSpPr>
@@ -26973,7 +26904,7 @@
       </p:sp>
       <p:sp>
         <p:nvSpPr>
-          <p:cNvPr id="28" name="Shape 23"/>
+          <p:cNvPr id="25" name="Shape 20"/>
           <p:cNvSpPr/>
           <p:nvPr/>
         </p:nvSpPr>
@@ -26993,7 +26924,7 @@
       </p:sp>
       <p:pic>
         <p:nvPicPr>
-          <p:cNvPr id="29" name="Image 3" descr="/tmp/claude-0/-home-user-doc-template-engine/198c21fb-8b4a-5b3c-a787-7fafcb963965/scratchpad/workshop/icons/gitbranch-white.png">    </p:cNvPr>
+          <p:cNvPr id="26" name="Image 3" descr="/tmp/claude-0/-home-user-doc-template-engine/198c21fb-8b4a-5b3c-a787-7fafcb963965/scratchpad/workshop/icons/gitbranch-white.png">    </p:cNvPr>
           <p:cNvPicPr>
             <a:picLocks noChangeAspect="1"/>
           </p:cNvPicPr>
@@ -27017,7 +26948,7 @@
       </p:pic>
       <p:sp>
         <p:nvSpPr>
-          <p:cNvPr id="30" name="Text 24"/>
+          <p:cNvPr id="27" name="Text 21"/>
           <p:cNvSpPr/>
           <p:nvPr/>
         </p:nvSpPr>
@@ -27056,7 +26987,7 @@
       </p:sp>
       <p:sp>
         <p:nvSpPr>
-          <p:cNvPr id="31" name="Text 25"/>
+          <p:cNvPr id="28" name="Text 22"/>
           <p:cNvSpPr/>
           <p:nvPr/>
         </p:nvSpPr>
@@ -27095,7 +27026,7 @@
       </p:sp>
       <p:sp>
         <p:nvSpPr>
-          <p:cNvPr id="32" name="Shape 26"/>
+          <p:cNvPr id="29" name="Shape 23"/>
           <p:cNvSpPr/>
           <p:nvPr/>
         </p:nvSpPr>
@@ -27115,7 +27046,7 @@
       </p:sp>
       <p:pic>
         <p:nvPicPr>
-          <p:cNvPr id="33" name="Image 4" descr="/tmp/claude-0/-home-user-doc-template-engine/198c21fb-8b4a-5b3c-a787-7fafcb963965/scratchpad/workshop/icons/search-white.png">    </p:cNvPr>
+          <p:cNvPr id="30" name="Image 4" descr="/tmp/claude-0/-home-user-doc-template-engine/198c21fb-8b4a-5b3c-a787-7fafcb963965/scratchpad/workshop/icons/search-white.png">    </p:cNvPr>
           <p:cNvPicPr>
             <a:picLocks noChangeAspect="1"/>
           </p:cNvPicPr>
@@ -27139,7 +27070,7 @@
       </p:pic>
       <p:sp>
         <p:nvSpPr>
-          <p:cNvPr id="34" name="Text 27"/>
+          <p:cNvPr id="31" name="Text 24"/>
           <p:cNvSpPr/>
           <p:nvPr/>
         </p:nvSpPr>
@@ -27198,7 +27129,7 @@
       </p:sp>
       <p:sp>
         <p:nvSpPr>
-          <p:cNvPr id="35" name="Shape 28"/>
+          <p:cNvPr id="32" name="Shape 25"/>
           <p:cNvSpPr/>
           <p:nvPr/>
         </p:nvSpPr>
@@ -27218,7 +27149,7 @@
       </p:sp>
       <p:pic>
         <p:nvPicPr>
-          <p:cNvPr id="36" name="Image 5" descr="/tmp/claude-0/-home-user-doc-template-engine/198c21fb-8b4a-5b3c-a787-7fafcb963965/scratchpad/workshop/icons/shield-white.png">    </p:cNvPr>
+          <p:cNvPr id="33" name="Image 5" descr="/tmp/claude-0/-home-user-doc-template-engine/198c21fb-8b4a-5b3c-a787-7fafcb963965/scratchpad/workshop/icons/shield-white.png">    </p:cNvPr>
           <p:cNvPicPr>
             <a:picLocks noChangeAspect="1"/>
           </p:cNvPicPr>
@@ -27242,7 +27173,7 @@
       </p:pic>
       <p:sp>
         <p:nvSpPr>
-          <p:cNvPr id="37" name="Text 29"/>
+          <p:cNvPr id="34" name="Text 26"/>
           <p:cNvSpPr/>
           <p:nvPr/>
         </p:nvSpPr>
@@ -27301,7 +27232,7 @@
       </p:sp>
       <p:sp>
         <p:nvSpPr>
-          <p:cNvPr id="38" name="Shape 30"/>
+          <p:cNvPr id="35" name="Shape 27"/>
           <p:cNvSpPr/>
           <p:nvPr/>
         </p:nvSpPr>
@@ -27321,7 +27252,7 @@
       </p:sp>
       <p:pic>
         <p:nvPicPr>
-          <p:cNvPr id="39" name="Image 6" descr="/tmp/claude-0/-home-user-doc-template-engine/198c21fb-8b4a-5b3c-a787-7fafcb963965/scratchpad/workshop/icons/users-white.png">    </p:cNvPr>
+          <p:cNvPr id="36" name="Image 6" descr="/tmp/claude-0/-home-user-doc-template-engine/198c21fb-8b4a-5b3c-a787-7fafcb963965/scratchpad/workshop/icons/users-white.png">    </p:cNvPr>
           <p:cNvPicPr>
             <a:picLocks noChangeAspect="1"/>
           </p:cNvPicPr>
@@ -27345,7 +27276,7 @@
       </p:pic>
       <p:sp>
         <p:nvSpPr>
-          <p:cNvPr id="40" name="Text 31"/>
+          <p:cNvPr id="37" name="Text 28"/>
           <p:cNvSpPr/>
           <p:nvPr/>
         </p:nvSpPr>

</xml_diff>

<commit_message>
Explica a origem do termo 'cheiros' no slide 32 (nota + rodapé)
Adiciona caption com a definição de smell (Beck & Fowler, Refactoring,
1999) sob o título e amplia as notas do apresentador com a explicação
do termo e a ponte de vocabulário gestor–dev.

Co-Authored-By: Claude Fable 5 <noreply@anthropic.com>
Claude-Session: https://claude.ai/code/session_017GrziW5UYuREHfRcnVVMio
</commit_message>
<xml_diff>
--- a/workshops/workshop-historias-usuario-documentacao.pptx
+++ b/workshops/workshop-historias-usuario-documentacao.pptx
@@ -2742,7 +2742,7 @@
           <a:p>
             <a:r>
               <a:rPr lang="en-US" dirty="0"/>
-              <a:t>5 min. Pergunte quantos desses cinco cheiros a plateia reconhece no Jira da casa — normalmente todos. Importante manter o tom construtivo: cheiro não é culpa de quem escreveu; é ausência de acordo sobre onde cada coisa mora. O acordo vem no fim do workshop.</a:t>
+              <a:t>5 min. Abra explicando o termo — 15 segundos que valem a pena: “cheiro” vem de code smell, expressão cunhada por Kent Beck e difundida por Martin Fowler em Refactoring (1999). Um cheiro é um indício barato de detectar que sugere um problema mais profundo: ele não é o erro em si, é o convite a investigar (a piada original do livro: “se fede, troque”). É o mesmo Kent Beck do XP do Bloco 1 — e é o vocabulário que os times de desenvolvimento já usam (code smell), então gestor e dev saem falando a mesma língua. Depois, pergunte quantos desses cinco cheiros a plateia reconhece no Jira da casa — normalmente todos. Importante manter o tom construtivo: cheiro não é culpa de quem escreveu; é ausência de acordo sobre onde cada coisa mora. O acordo vem no fim do workshop.</a:t>
             </a:r>
             <a:endParaRPr lang="en-US" dirty="0"/>
           </a:p>
@@ -30692,13 +30692,52 @@
       </p:sp>
       <p:sp>
         <p:nvSpPr>
-          <p:cNvPr id="6" name="Shape 4"/>
-          <p:cNvSpPr/>
-          <p:nvPr/>
-        </p:nvSpPr>
-        <p:spPr>
-          <a:xfrm>
-            <a:off x="594360" y="1417320"/>
+          <p:cNvPr id="6" name="Text 4"/>
+          <p:cNvSpPr/>
+          <p:nvPr/>
+        </p:nvSpPr>
+        <p:spPr>
+          <a:xfrm>
+            <a:off x="594360" y="1207008"/>
+            <a:ext cx="11000232" cy="237744"/>
+          </a:xfrm>
+          <a:prstGeom prst="rect">
+            <a:avLst/>
+          </a:prstGeom>
+          <a:noFill/>
+          <a:ln/>
+        </p:spPr>
+        <p:txBody>
+          <a:bodyPr wrap="square" lIns="0" tIns="0" rIns="0" bIns="0" rtlCol="0" anchor="ctr"/>
+          <a:lstStyle/>
+          <a:p>
+            <a:pPr indent="0" marL="0">
+              <a:buNone/>
+            </a:pPr>
+            <a:r>
+              <a:rPr lang="en-US" sz="1000" i="1" dirty="0">
+                <a:solidFill>
+                  <a:srgbClr val="5B6B84"/>
+                </a:solidFill>
+                <a:latin typeface="Calibri" pitchFamily="34" charset="0"/>
+                <a:ea typeface="Calibri" pitchFamily="34" charset="-122"/>
+                <a:cs typeface="Calibri" pitchFamily="34" charset="-120"/>
+              </a:rPr>
+              <a:t>“Cheiro” (do inglês smell): um indício na superfície que costuma apontar um problema mais profundo — Kent Beck &amp; Martin Fowler, Refactoring, 1999.</a:t>
+            </a:r>
+            <a:endParaRPr lang="en-US" sz="1000" dirty="0"/>
+          </a:p>
+        </p:txBody>
+      </p:sp>
+      <p:sp>
+        <p:nvSpPr>
+          <p:cNvPr id="7" name="Shape 5"/>
+          <p:cNvSpPr/>
+          <p:nvPr/>
+        </p:nvSpPr>
+        <p:spPr>
+          <a:xfrm>
+            <a:off x="594360" y="1536192"/>
             <a:ext cx="4892040" cy="786384"/>
           </a:xfrm>
           <a:prstGeom prst="roundRect">
@@ -30719,13 +30758,13 @@
       </p:sp>
       <p:sp>
         <p:nvSpPr>
-          <p:cNvPr id="7" name="Shape 5"/>
-          <p:cNvSpPr/>
-          <p:nvPr/>
-        </p:nvSpPr>
-        <p:spPr>
-          <a:xfrm>
-            <a:off x="758952" y="1618488"/>
+          <p:cNvPr id="8" name="Shape 6"/>
+          <p:cNvSpPr/>
+          <p:nvPr/>
+        </p:nvSpPr>
+        <p:spPr>
+          <a:xfrm>
+            <a:off x="758952" y="1737360"/>
             <a:ext cx="365760" cy="365760"/>
           </a:xfrm>
           <a:prstGeom prst="ellipse">
@@ -30739,7 +30778,7 @@
       </p:sp>
       <p:pic>
         <p:nvPicPr>
-          <p:cNvPr id="8" name="Image 0" descr="/tmp/claude-0/-home-user-doc-template-engine/198c21fb-8b4a-5b3c-a787-7fafcb963965/scratchpad/workshop/icons/search-white.png">    </p:cNvPr>
+          <p:cNvPr id="9" name="Image 0" descr="/tmp/claude-0/-home-user-doc-template-engine/198c21fb-8b4a-5b3c-a787-7fafcb963965/scratchpad/workshop/icons/search-white.png">    </p:cNvPr>
           <p:cNvPicPr>
             <a:picLocks noChangeAspect="1"/>
           </p:cNvPicPr>
@@ -30753,7 +30792,7 @@
         </p:blipFill>
         <p:spPr>
           <a:xfrm>
-            <a:off x="857707" y="1717243"/>
+            <a:off x="857707" y="1836115"/>
             <a:ext cx="168250" cy="168250"/>
           </a:xfrm>
           <a:prstGeom prst="rect">
@@ -30763,13 +30802,13 @@
       </p:pic>
       <p:sp>
         <p:nvSpPr>
-          <p:cNvPr id="9" name="Text 6"/>
-          <p:cNvSpPr/>
-          <p:nvPr/>
-        </p:nvSpPr>
-        <p:spPr>
-          <a:xfrm>
-            <a:off x="1261872" y="1417320"/>
+          <p:cNvPr id="10" name="Text 7"/>
+          <p:cNvSpPr/>
+          <p:nvPr/>
+        </p:nvSpPr>
+        <p:spPr>
+          <a:xfrm>
+            <a:off x="1261872" y="1536192"/>
             <a:ext cx="4114800" cy="786384"/>
           </a:xfrm>
           <a:prstGeom prst="rect">
@@ -30802,13 +30841,13 @@
       </p:sp>
       <p:sp>
         <p:nvSpPr>
-          <p:cNvPr id="10" name="Shape 7"/>
-          <p:cNvSpPr/>
-          <p:nvPr/>
-        </p:nvSpPr>
-        <p:spPr>
-          <a:xfrm>
-            <a:off x="5614416" y="1810512"/>
+          <p:cNvPr id="11" name="Shape 8"/>
+          <p:cNvSpPr/>
+          <p:nvPr/>
+        </p:nvSpPr>
+        <p:spPr>
+          <a:xfrm>
+            <a:off x="5614416" y="1929384"/>
             <a:ext cx="384048" cy="0"/>
           </a:xfrm>
           <a:prstGeom prst="line">
@@ -30826,13 +30865,13 @@
       </p:sp>
       <p:sp>
         <p:nvSpPr>
-          <p:cNvPr id="11" name="Shape 8"/>
-          <p:cNvSpPr/>
-          <p:nvPr/>
-        </p:nvSpPr>
-        <p:spPr>
-          <a:xfrm>
-            <a:off x="6126480" y="1417320"/>
+          <p:cNvPr id="12" name="Shape 9"/>
+          <p:cNvSpPr/>
+          <p:nvPr/>
+        </p:nvSpPr>
+        <p:spPr>
+          <a:xfrm>
+            <a:off x="6126480" y="1536192"/>
             <a:ext cx="5486400" cy="786384"/>
           </a:xfrm>
           <a:prstGeom prst="roundRect">
@@ -30853,13 +30892,13 @@
       </p:sp>
       <p:sp>
         <p:nvSpPr>
-          <p:cNvPr id="12" name="Shape 9"/>
-          <p:cNvSpPr/>
-          <p:nvPr/>
-        </p:nvSpPr>
-        <p:spPr>
-          <a:xfrm>
-            <a:off x="6291072" y="1618488"/>
+          <p:cNvPr id="13" name="Shape 10"/>
+          <p:cNvSpPr/>
+          <p:nvPr/>
+        </p:nvSpPr>
+        <p:spPr>
+          <a:xfrm>
+            <a:off x="6291072" y="1737360"/>
             <a:ext cx="365760" cy="365760"/>
           </a:xfrm>
           <a:prstGeom prst="ellipse">
@@ -30873,7 +30912,7 @@
       </p:sp>
       <p:pic>
         <p:nvPicPr>
-          <p:cNvPr id="13" name="Image 1" descr="/tmp/claude-0/-home-user-doc-template-engine/198c21fb-8b4a-5b3c-a787-7fafcb963965/scratchpad/workshop/icons/checkmini-white.png">    </p:cNvPr>
+          <p:cNvPr id="14" name="Image 1" descr="/tmp/claude-0/-home-user-doc-template-engine/198c21fb-8b4a-5b3c-a787-7fafcb963965/scratchpad/workshop/icons/checkmini-white.png">    </p:cNvPr>
           <p:cNvPicPr>
             <a:picLocks noChangeAspect="1"/>
           </p:cNvPicPr>
@@ -30887,7 +30926,7 @@
         </p:blipFill>
         <p:spPr>
           <a:xfrm>
-            <a:off x="6389827" y="1717243"/>
+            <a:off x="6389827" y="1836115"/>
             <a:ext cx="168250" cy="168250"/>
           </a:xfrm>
           <a:prstGeom prst="rect">
@@ -30897,13 +30936,13 @@
       </p:pic>
       <p:sp>
         <p:nvSpPr>
-          <p:cNvPr id="14" name="Text 10"/>
-          <p:cNvSpPr/>
-          <p:nvPr/>
-        </p:nvSpPr>
-        <p:spPr>
-          <a:xfrm>
-            <a:off x="6793992" y="1417320"/>
+          <p:cNvPr id="15" name="Text 11"/>
+          <p:cNvSpPr/>
+          <p:nvPr/>
+        </p:nvSpPr>
+        <p:spPr>
+          <a:xfrm>
+            <a:off x="6793992" y="1536192"/>
             <a:ext cx="4663440" cy="786384"/>
           </a:xfrm>
           <a:prstGeom prst="rect">
@@ -30936,13 +30975,13 @@
       </p:sp>
       <p:sp>
         <p:nvSpPr>
-          <p:cNvPr id="15" name="Shape 11"/>
-          <p:cNvSpPr/>
-          <p:nvPr/>
-        </p:nvSpPr>
-        <p:spPr>
-          <a:xfrm>
-            <a:off x="594360" y="2350008"/>
+          <p:cNvPr id="16" name="Shape 12"/>
+          <p:cNvSpPr/>
+          <p:nvPr/>
+        </p:nvSpPr>
+        <p:spPr>
+          <a:xfrm>
+            <a:off x="594360" y="2450592"/>
             <a:ext cx="4892040" cy="786384"/>
           </a:xfrm>
           <a:prstGeom prst="roundRect">
@@ -30963,13 +31002,13 @@
       </p:sp>
       <p:sp>
         <p:nvSpPr>
-          <p:cNvPr id="16" name="Shape 12"/>
-          <p:cNvSpPr/>
-          <p:nvPr/>
-        </p:nvSpPr>
-        <p:spPr>
-          <a:xfrm>
-            <a:off x="758952" y="2551176"/>
+          <p:cNvPr id="17" name="Shape 13"/>
+          <p:cNvSpPr/>
+          <p:nvPr/>
+        </p:nvSpPr>
+        <p:spPr>
+          <a:xfrm>
+            <a:off x="758952" y="2651760"/>
             <a:ext cx="365760" cy="365760"/>
           </a:xfrm>
           <a:prstGeom prst="ellipse">
@@ -30983,7 +31022,7 @@
       </p:sp>
       <p:pic>
         <p:nvPicPr>
-          <p:cNvPr id="17" name="Image 2" descr="/tmp/claude-0/-home-user-doc-template-engine/198c21fb-8b4a-5b3c-a787-7fafcb963965/scratchpad/workshop/icons/search-white.png">    </p:cNvPr>
+          <p:cNvPr id="18" name="Image 2" descr="/tmp/claude-0/-home-user-doc-template-engine/198c21fb-8b4a-5b3c-a787-7fafcb963965/scratchpad/workshop/icons/search-white.png">    </p:cNvPr>
           <p:cNvPicPr>
             <a:picLocks noChangeAspect="1"/>
           </p:cNvPicPr>
@@ -30997,7 +31036,7 @@
         </p:blipFill>
         <p:spPr>
           <a:xfrm>
-            <a:off x="857707" y="2649931"/>
+            <a:off x="857707" y="2750515"/>
             <a:ext cx="168250" cy="168250"/>
           </a:xfrm>
           <a:prstGeom prst="rect">
@@ -31007,13 +31046,13 @@
       </p:pic>
       <p:sp>
         <p:nvSpPr>
-          <p:cNvPr id="18" name="Text 13"/>
-          <p:cNvSpPr/>
-          <p:nvPr/>
-        </p:nvSpPr>
-        <p:spPr>
-          <a:xfrm>
-            <a:off x="1261872" y="2350008"/>
+          <p:cNvPr id="19" name="Text 14"/>
+          <p:cNvSpPr/>
+          <p:nvPr/>
+        </p:nvSpPr>
+        <p:spPr>
+          <a:xfrm>
+            <a:off x="1261872" y="2450592"/>
             <a:ext cx="4114800" cy="786384"/>
           </a:xfrm>
           <a:prstGeom prst="rect">
@@ -31046,13 +31085,13 @@
       </p:sp>
       <p:sp>
         <p:nvSpPr>
-          <p:cNvPr id="19" name="Shape 14"/>
-          <p:cNvSpPr/>
-          <p:nvPr/>
-        </p:nvSpPr>
-        <p:spPr>
-          <a:xfrm>
-            <a:off x="5614416" y="2743200"/>
+          <p:cNvPr id="20" name="Shape 15"/>
+          <p:cNvSpPr/>
+          <p:nvPr/>
+        </p:nvSpPr>
+        <p:spPr>
+          <a:xfrm>
+            <a:off x="5614416" y="2843784"/>
             <a:ext cx="384048" cy="0"/>
           </a:xfrm>
           <a:prstGeom prst="line">
@@ -31070,13 +31109,13 @@
       </p:sp>
       <p:sp>
         <p:nvSpPr>
-          <p:cNvPr id="20" name="Shape 15"/>
-          <p:cNvSpPr/>
-          <p:nvPr/>
-        </p:nvSpPr>
-        <p:spPr>
-          <a:xfrm>
-            <a:off x="6126480" y="2350008"/>
+          <p:cNvPr id="21" name="Shape 16"/>
+          <p:cNvSpPr/>
+          <p:nvPr/>
+        </p:nvSpPr>
+        <p:spPr>
+          <a:xfrm>
+            <a:off x="6126480" y="2450592"/>
             <a:ext cx="5486400" cy="786384"/>
           </a:xfrm>
           <a:prstGeom prst="roundRect">
@@ -31097,13 +31136,13 @@
       </p:sp>
       <p:sp>
         <p:nvSpPr>
-          <p:cNvPr id="21" name="Shape 16"/>
-          <p:cNvSpPr/>
-          <p:nvPr/>
-        </p:nvSpPr>
-        <p:spPr>
-          <a:xfrm>
-            <a:off x="6291072" y="2551176"/>
+          <p:cNvPr id="22" name="Shape 17"/>
+          <p:cNvSpPr/>
+          <p:nvPr/>
+        </p:nvSpPr>
+        <p:spPr>
+          <a:xfrm>
+            <a:off x="6291072" y="2651760"/>
             <a:ext cx="365760" cy="365760"/>
           </a:xfrm>
           <a:prstGeom prst="ellipse">
@@ -31117,7 +31156,7 @@
       </p:sp>
       <p:pic>
         <p:nvPicPr>
-          <p:cNvPr id="22" name="Image 3" descr="/tmp/claude-0/-home-user-doc-template-engine/198c21fb-8b4a-5b3c-a787-7fafcb963965/scratchpad/workshop/icons/checkmini-white.png">    </p:cNvPr>
+          <p:cNvPr id="23" name="Image 3" descr="/tmp/claude-0/-home-user-doc-template-engine/198c21fb-8b4a-5b3c-a787-7fafcb963965/scratchpad/workshop/icons/checkmini-white.png">    </p:cNvPr>
           <p:cNvPicPr>
             <a:picLocks noChangeAspect="1"/>
           </p:cNvPicPr>
@@ -31131,7 +31170,7 @@
         </p:blipFill>
         <p:spPr>
           <a:xfrm>
-            <a:off x="6389827" y="2649931"/>
+            <a:off x="6389827" y="2750515"/>
             <a:ext cx="168250" cy="168250"/>
           </a:xfrm>
           <a:prstGeom prst="rect">
@@ -31141,13 +31180,13 @@
       </p:pic>
       <p:sp>
         <p:nvSpPr>
-          <p:cNvPr id="23" name="Text 17"/>
-          <p:cNvSpPr/>
-          <p:nvPr/>
-        </p:nvSpPr>
-        <p:spPr>
-          <a:xfrm>
-            <a:off x="6793992" y="2350008"/>
+          <p:cNvPr id="24" name="Text 18"/>
+          <p:cNvSpPr/>
+          <p:nvPr/>
+        </p:nvSpPr>
+        <p:spPr>
+          <a:xfrm>
+            <a:off x="6793992" y="2450592"/>
             <a:ext cx="4663440" cy="786384"/>
           </a:xfrm>
           <a:prstGeom prst="rect">
@@ -31180,13 +31219,13 @@
       </p:sp>
       <p:sp>
         <p:nvSpPr>
-          <p:cNvPr id="24" name="Shape 18"/>
-          <p:cNvSpPr/>
-          <p:nvPr/>
-        </p:nvSpPr>
-        <p:spPr>
-          <a:xfrm>
-            <a:off x="594360" y="3282696"/>
+          <p:cNvPr id="25" name="Shape 19"/>
+          <p:cNvSpPr/>
+          <p:nvPr/>
+        </p:nvSpPr>
+        <p:spPr>
+          <a:xfrm>
+            <a:off x="594360" y="3364992"/>
             <a:ext cx="4892040" cy="786384"/>
           </a:xfrm>
           <a:prstGeom prst="roundRect">
@@ -31207,13 +31246,13 @@
       </p:sp>
       <p:sp>
         <p:nvSpPr>
-          <p:cNvPr id="25" name="Shape 19"/>
-          <p:cNvSpPr/>
-          <p:nvPr/>
-        </p:nvSpPr>
-        <p:spPr>
-          <a:xfrm>
-            <a:off x="758952" y="3483864"/>
+          <p:cNvPr id="26" name="Shape 20"/>
+          <p:cNvSpPr/>
+          <p:nvPr/>
+        </p:nvSpPr>
+        <p:spPr>
+          <a:xfrm>
+            <a:off x="758952" y="3566160"/>
             <a:ext cx="365760" cy="365760"/>
           </a:xfrm>
           <a:prstGeom prst="ellipse">
@@ -31227,7 +31266,7 @@
       </p:sp>
       <p:pic>
         <p:nvPicPr>
-          <p:cNvPr id="26" name="Image 4" descr="/tmp/claude-0/-home-user-doc-template-engine/198c21fb-8b4a-5b3c-a787-7fafcb963965/scratchpad/workshop/icons/search-white.png">    </p:cNvPr>
+          <p:cNvPr id="27" name="Image 4" descr="/tmp/claude-0/-home-user-doc-template-engine/198c21fb-8b4a-5b3c-a787-7fafcb963965/scratchpad/workshop/icons/search-white.png">    </p:cNvPr>
           <p:cNvPicPr>
             <a:picLocks noChangeAspect="1"/>
           </p:cNvPicPr>
@@ -31241,7 +31280,7 @@
         </p:blipFill>
         <p:spPr>
           <a:xfrm>
-            <a:off x="857707" y="3582619"/>
+            <a:off x="857707" y="3664915"/>
             <a:ext cx="168250" cy="168250"/>
           </a:xfrm>
           <a:prstGeom prst="rect">
@@ -31251,13 +31290,13 @@
       </p:pic>
       <p:sp>
         <p:nvSpPr>
-          <p:cNvPr id="27" name="Text 20"/>
-          <p:cNvSpPr/>
-          <p:nvPr/>
-        </p:nvSpPr>
-        <p:spPr>
-          <a:xfrm>
-            <a:off x="1261872" y="3282696"/>
+          <p:cNvPr id="28" name="Text 21"/>
+          <p:cNvSpPr/>
+          <p:nvPr/>
+        </p:nvSpPr>
+        <p:spPr>
+          <a:xfrm>
+            <a:off x="1261872" y="3364992"/>
             <a:ext cx="4114800" cy="786384"/>
           </a:xfrm>
           <a:prstGeom prst="rect">
@@ -31290,13 +31329,13 @@
       </p:sp>
       <p:sp>
         <p:nvSpPr>
-          <p:cNvPr id="28" name="Shape 21"/>
-          <p:cNvSpPr/>
-          <p:nvPr/>
-        </p:nvSpPr>
-        <p:spPr>
-          <a:xfrm>
-            <a:off x="5614416" y="3675888"/>
+          <p:cNvPr id="29" name="Shape 22"/>
+          <p:cNvSpPr/>
+          <p:nvPr/>
+        </p:nvSpPr>
+        <p:spPr>
+          <a:xfrm>
+            <a:off x="5614416" y="3758184"/>
             <a:ext cx="384048" cy="0"/>
           </a:xfrm>
           <a:prstGeom prst="line">
@@ -31314,13 +31353,13 @@
       </p:sp>
       <p:sp>
         <p:nvSpPr>
-          <p:cNvPr id="29" name="Shape 22"/>
-          <p:cNvSpPr/>
-          <p:nvPr/>
-        </p:nvSpPr>
-        <p:spPr>
-          <a:xfrm>
-            <a:off x="6126480" y="3282696"/>
+          <p:cNvPr id="30" name="Shape 23"/>
+          <p:cNvSpPr/>
+          <p:nvPr/>
+        </p:nvSpPr>
+        <p:spPr>
+          <a:xfrm>
+            <a:off x="6126480" y="3364992"/>
             <a:ext cx="5486400" cy="786384"/>
           </a:xfrm>
           <a:prstGeom prst="roundRect">
@@ -31341,13 +31380,13 @@
       </p:sp>
       <p:sp>
         <p:nvSpPr>
-          <p:cNvPr id="30" name="Shape 23"/>
-          <p:cNvSpPr/>
-          <p:nvPr/>
-        </p:nvSpPr>
-        <p:spPr>
-          <a:xfrm>
-            <a:off x="6291072" y="3483864"/>
+          <p:cNvPr id="31" name="Shape 24"/>
+          <p:cNvSpPr/>
+          <p:nvPr/>
+        </p:nvSpPr>
+        <p:spPr>
+          <a:xfrm>
+            <a:off x="6291072" y="3566160"/>
             <a:ext cx="365760" cy="365760"/>
           </a:xfrm>
           <a:prstGeom prst="ellipse">
@@ -31361,7 +31400,7 @@
       </p:sp>
       <p:pic>
         <p:nvPicPr>
-          <p:cNvPr id="31" name="Image 5" descr="/tmp/claude-0/-home-user-doc-template-engine/198c21fb-8b4a-5b3c-a787-7fafcb963965/scratchpad/workshop/icons/checkmini-white.png">    </p:cNvPr>
+          <p:cNvPr id="32" name="Image 5" descr="/tmp/claude-0/-home-user-doc-template-engine/198c21fb-8b4a-5b3c-a787-7fafcb963965/scratchpad/workshop/icons/checkmini-white.png">    </p:cNvPr>
           <p:cNvPicPr>
             <a:picLocks noChangeAspect="1"/>
           </p:cNvPicPr>
@@ -31375,7 +31414,7 @@
         </p:blipFill>
         <p:spPr>
           <a:xfrm>
-            <a:off x="6389827" y="3582619"/>
+            <a:off x="6389827" y="3664915"/>
             <a:ext cx="168250" cy="168250"/>
           </a:xfrm>
           <a:prstGeom prst="rect">
@@ -31385,13 +31424,13 @@
       </p:pic>
       <p:sp>
         <p:nvSpPr>
-          <p:cNvPr id="32" name="Text 24"/>
-          <p:cNvSpPr/>
-          <p:nvPr/>
-        </p:nvSpPr>
-        <p:spPr>
-          <a:xfrm>
-            <a:off x="6793992" y="3282696"/>
+          <p:cNvPr id="33" name="Text 25"/>
+          <p:cNvSpPr/>
+          <p:nvPr/>
+        </p:nvSpPr>
+        <p:spPr>
+          <a:xfrm>
+            <a:off x="6793992" y="3364992"/>
             <a:ext cx="4663440" cy="786384"/>
           </a:xfrm>
           <a:prstGeom prst="rect">
@@ -31424,13 +31463,13 @@
       </p:sp>
       <p:sp>
         <p:nvSpPr>
-          <p:cNvPr id="33" name="Shape 25"/>
-          <p:cNvSpPr/>
-          <p:nvPr/>
-        </p:nvSpPr>
-        <p:spPr>
-          <a:xfrm>
-            <a:off x="594360" y="4215384"/>
+          <p:cNvPr id="34" name="Shape 26"/>
+          <p:cNvSpPr/>
+          <p:nvPr/>
+        </p:nvSpPr>
+        <p:spPr>
+          <a:xfrm>
+            <a:off x="594360" y="4279392"/>
             <a:ext cx="4892040" cy="786384"/>
           </a:xfrm>
           <a:prstGeom prst="roundRect">
@@ -31451,13 +31490,13 @@
       </p:sp>
       <p:sp>
         <p:nvSpPr>
-          <p:cNvPr id="34" name="Shape 26"/>
-          <p:cNvSpPr/>
-          <p:nvPr/>
-        </p:nvSpPr>
-        <p:spPr>
-          <a:xfrm>
-            <a:off x="758952" y="4416552"/>
+          <p:cNvPr id="35" name="Shape 27"/>
+          <p:cNvSpPr/>
+          <p:nvPr/>
+        </p:nvSpPr>
+        <p:spPr>
+          <a:xfrm>
+            <a:off x="758952" y="4480560"/>
             <a:ext cx="365760" cy="365760"/>
           </a:xfrm>
           <a:prstGeom prst="ellipse">
@@ -31471,7 +31510,7 @@
       </p:sp>
       <p:pic>
         <p:nvPicPr>
-          <p:cNvPr id="35" name="Image 6" descr="/tmp/claude-0/-home-user-doc-template-engine/198c21fb-8b4a-5b3c-a787-7fafcb963965/scratchpad/workshop/icons/search-white.png">    </p:cNvPr>
+          <p:cNvPr id="36" name="Image 6" descr="/tmp/claude-0/-home-user-doc-template-engine/198c21fb-8b4a-5b3c-a787-7fafcb963965/scratchpad/workshop/icons/search-white.png">    </p:cNvPr>
           <p:cNvPicPr>
             <a:picLocks noChangeAspect="1"/>
           </p:cNvPicPr>
@@ -31485,7 +31524,7 @@
         </p:blipFill>
         <p:spPr>
           <a:xfrm>
-            <a:off x="857707" y="4515307"/>
+            <a:off x="857707" y="4579315"/>
             <a:ext cx="168250" cy="168250"/>
           </a:xfrm>
           <a:prstGeom prst="rect">
@@ -31495,13 +31534,13 @@
       </p:pic>
       <p:sp>
         <p:nvSpPr>
-          <p:cNvPr id="36" name="Text 27"/>
-          <p:cNvSpPr/>
-          <p:nvPr/>
-        </p:nvSpPr>
-        <p:spPr>
-          <a:xfrm>
-            <a:off x="1261872" y="4215384"/>
+          <p:cNvPr id="37" name="Text 28"/>
+          <p:cNvSpPr/>
+          <p:nvPr/>
+        </p:nvSpPr>
+        <p:spPr>
+          <a:xfrm>
+            <a:off x="1261872" y="4279392"/>
             <a:ext cx="4114800" cy="786384"/>
           </a:xfrm>
           <a:prstGeom prst="rect">
@@ -31534,13 +31573,13 @@
       </p:sp>
       <p:sp>
         <p:nvSpPr>
-          <p:cNvPr id="37" name="Shape 28"/>
-          <p:cNvSpPr/>
-          <p:nvPr/>
-        </p:nvSpPr>
-        <p:spPr>
-          <a:xfrm>
-            <a:off x="5614416" y="4608576"/>
+          <p:cNvPr id="38" name="Shape 29"/>
+          <p:cNvSpPr/>
+          <p:nvPr/>
+        </p:nvSpPr>
+        <p:spPr>
+          <a:xfrm>
+            <a:off x="5614416" y="4672584"/>
             <a:ext cx="384048" cy="0"/>
           </a:xfrm>
           <a:prstGeom prst="line">
@@ -31558,13 +31597,13 @@
       </p:sp>
       <p:sp>
         <p:nvSpPr>
-          <p:cNvPr id="38" name="Shape 29"/>
-          <p:cNvSpPr/>
-          <p:nvPr/>
-        </p:nvSpPr>
-        <p:spPr>
-          <a:xfrm>
-            <a:off x="6126480" y="4215384"/>
+          <p:cNvPr id="39" name="Shape 30"/>
+          <p:cNvSpPr/>
+          <p:nvPr/>
+        </p:nvSpPr>
+        <p:spPr>
+          <a:xfrm>
+            <a:off x="6126480" y="4279392"/>
             <a:ext cx="5486400" cy="786384"/>
           </a:xfrm>
           <a:prstGeom prst="roundRect">
@@ -31585,13 +31624,13 @@
       </p:sp>
       <p:sp>
         <p:nvSpPr>
-          <p:cNvPr id="39" name="Shape 30"/>
-          <p:cNvSpPr/>
-          <p:nvPr/>
-        </p:nvSpPr>
-        <p:spPr>
-          <a:xfrm>
-            <a:off x="6291072" y="4416552"/>
+          <p:cNvPr id="40" name="Shape 31"/>
+          <p:cNvSpPr/>
+          <p:nvPr/>
+        </p:nvSpPr>
+        <p:spPr>
+          <a:xfrm>
+            <a:off x="6291072" y="4480560"/>
             <a:ext cx="365760" cy="365760"/>
           </a:xfrm>
           <a:prstGeom prst="ellipse">
@@ -31605,7 +31644,7 @@
       </p:sp>
       <p:pic>
         <p:nvPicPr>
-          <p:cNvPr id="40" name="Image 7" descr="/tmp/claude-0/-home-user-doc-template-engine/198c21fb-8b4a-5b3c-a787-7fafcb963965/scratchpad/workshop/icons/checkmini-white.png">    </p:cNvPr>
+          <p:cNvPr id="41" name="Image 7" descr="/tmp/claude-0/-home-user-doc-template-engine/198c21fb-8b4a-5b3c-a787-7fafcb963965/scratchpad/workshop/icons/checkmini-white.png">    </p:cNvPr>
           <p:cNvPicPr>
             <a:picLocks noChangeAspect="1"/>
           </p:cNvPicPr>
@@ -31619,7 +31658,7 @@
         </p:blipFill>
         <p:spPr>
           <a:xfrm>
-            <a:off x="6389827" y="4515307"/>
+            <a:off x="6389827" y="4579315"/>
             <a:ext cx="168250" cy="168250"/>
           </a:xfrm>
           <a:prstGeom prst="rect">
@@ -31629,13 +31668,13 @@
       </p:pic>
       <p:sp>
         <p:nvSpPr>
-          <p:cNvPr id="41" name="Text 31"/>
-          <p:cNvSpPr/>
-          <p:nvPr/>
-        </p:nvSpPr>
-        <p:spPr>
-          <a:xfrm>
-            <a:off x="6793992" y="4215384"/>
+          <p:cNvPr id="42" name="Text 32"/>
+          <p:cNvSpPr/>
+          <p:nvPr/>
+        </p:nvSpPr>
+        <p:spPr>
+          <a:xfrm>
+            <a:off x="6793992" y="4279392"/>
             <a:ext cx="4663440" cy="786384"/>
           </a:xfrm>
           <a:prstGeom prst="rect">
@@ -31668,13 +31707,13 @@
       </p:sp>
       <p:sp>
         <p:nvSpPr>
-          <p:cNvPr id="42" name="Shape 32"/>
-          <p:cNvSpPr/>
-          <p:nvPr/>
-        </p:nvSpPr>
-        <p:spPr>
-          <a:xfrm>
-            <a:off x="594360" y="5148072"/>
+          <p:cNvPr id="43" name="Shape 33"/>
+          <p:cNvSpPr/>
+          <p:nvPr/>
+        </p:nvSpPr>
+        <p:spPr>
+          <a:xfrm>
+            <a:off x="594360" y="5193792"/>
             <a:ext cx="4892040" cy="786384"/>
           </a:xfrm>
           <a:prstGeom prst="roundRect">
@@ -31695,13 +31734,13 @@
       </p:sp>
       <p:sp>
         <p:nvSpPr>
-          <p:cNvPr id="43" name="Shape 33"/>
-          <p:cNvSpPr/>
-          <p:nvPr/>
-        </p:nvSpPr>
-        <p:spPr>
-          <a:xfrm>
-            <a:off x="758952" y="5349240"/>
+          <p:cNvPr id="44" name="Shape 34"/>
+          <p:cNvSpPr/>
+          <p:nvPr/>
+        </p:nvSpPr>
+        <p:spPr>
+          <a:xfrm>
+            <a:off x="758952" y="5394960"/>
             <a:ext cx="365760" cy="365760"/>
           </a:xfrm>
           <a:prstGeom prst="ellipse">
@@ -31715,7 +31754,7 @@
       </p:sp>
       <p:pic>
         <p:nvPicPr>
-          <p:cNvPr id="44" name="Image 8" descr="/tmp/claude-0/-home-user-doc-template-engine/198c21fb-8b4a-5b3c-a787-7fafcb963965/scratchpad/workshop/icons/search-white.png">    </p:cNvPr>
+          <p:cNvPr id="45" name="Image 8" descr="/tmp/claude-0/-home-user-doc-template-engine/198c21fb-8b4a-5b3c-a787-7fafcb963965/scratchpad/workshop/icons/search-white.png">    </p:cNvPr>
           <p:cNvPicPr>
             <a:picLocks noChangeAspect="1"/>
           </p:cNvPicPr>
@@ -31729,7 +31768,7 @@
         </p:blipFill>
         <p:spPr>
           <a:xfrm>
-            <a:off x="857707" y="5447995"/>
+            <a:off x="857707" y="5493715"/>
             <a:ext cx="168250" cy="168250"/>
           </a:xfrm>
           <a:prstGeom prst="rect">
@@ -31739,13 +31778,13 @@
       </p:pic>
       <p:sp>
         <p:nvSpPr>
-          <p:cNvPr id="45" name="Text 34"/>
-          <p:cNvSpPr/>
-          <p:nvPr/>
-        </p:nvSpPr>
-        <p:spPr>
-          <a:xfrm>
-            <a:off x="1261872" y="5148072"/>
+          <p:cNvPr id="46" name="Text 35"/>
+          <p:cNvSpPr/>
+          <p:nvPr/>
+        </p:nvSpPr>
+        <p:spPr>
+          <a:xfrm>
+            <a:off x="1261872" y="5193792"/>
             <a:ext cx="4114800" cy="786384"/>
           </a:xfrm>
           <a:prstGeom prst="rect">
@@ -31778,13 +31817,13 @@
       </p:sp>
       <p:sp>
         <p:nvSpPr>
-          <p:cNvPr id="46" name="Shape 35"/>
-          <p:cNvSpPr/>
-          <p:nvPr/>
-        </p:nvSpPr>
-        <p:spPr>
-          <a:xfrm>
-            <a:off x="5614416" y="5541264"/>
+          <p:cNvPr id="47" name="Shape 36"/>
+          <p:cNvSpPr/>
+          <p:nvPr/>
+        </p:nvSpPr>
+        <p:spPr>
+          <a:xfrm>
+            <a:off x="5614416" y="5586984"/>
             <a:ext cx="384048" cy="0"/>
           </a:xfrm>
           <a:prstGeom prst="line">
@@ -31802,13 +31841,13 @@
       </p:sp>
       <p:sp>
         <p:nvSpPr>
-          <p:cNvPr id="47" name="Shape 36"/>
-          <p:cNvSpPr/>
-          <p:nvPr/>
-        </p:nvSpPr>
-        <p:spPr>
-          <a:xfrm>
-            <a:off x="6126480" y="5148072"/>
+          <p:cNvPr id="48" name="Shape 37"/>
+          <p:cNvSpPr/>
+          <p:nvPr/>
+        </p:nvSpPr>
+        <p:spPr>
+          <a:xfrm>
+            <a:off x="6126480" y="5193792"/>
             <a:ext cx="5486400" cy="786384"/>
           </a:xfrm>
           <a:prstGeom prst="roundRect">
@@ -31829,13 +31868,13 @@
       </p:sp>
       <p:sp>
         <p:nvSpPr>
-          <p:cNvPr id="48" name="Shape 37"/>
-          <p:cNvSpPr/>
-          <p:nvPr/>
-        </p:nvSpPr>
-        <p:spPr>
-          <a:xfrm>
-            <a:off x="6291072" y="5349240"/>
+          <p:cNvPr id="49" name="Shape 38"/>
+          <p:cNvSpPr/>
+          <p:nvPr/>
+        </p:nvSpPr>
+        <p:spPr>
+          <a:xfrm>
+            <a:off x="6291072" y="5394960"/>
             <a:ext cx="365760" cy="365760"/>
           </a:xfrm>
           <a:prstGeom prst="ellipse">
@@ -31849,7 +31888,7 @@
       </p:sp>
       <p:pic>
         <p:nvPicPr>
-          <p:cNvPr id="49" name="Image 9" descr="/tmp/claude-0/-home-user-doc-template-engine/198c21fb-8b4a-5b3c-a787-7fafcb963965/scratchpad/workshop/icons/checkmini-white.png">    </p:cNvPr>
+          <p:cNvPr id="50" name="Image 9" descr="/tmp/claude-0/-home-user-doc-template-engine/198c21fb-8b4a-5b3c-a787-7fafcb963965/scratchpad/workshop/icons/checkmini-white.png">    </p:cNvPr>
           <p:cNvPicPr>
             <a:picLocks noChangeAspect="1"/>
           </p:cNvPicPr>
@@ -31863,7 +31902,7 @@
         </p:blipFill>
         <p:spPr>
           <a:xfrm>
-            <a:off x="6389827" y="5447995"/>
+            <a:off x="6389827" y="5493715"/>
             <a:ext cx="168250" cy="168250"/>
           </a:xfrm>
           <a:prstGeom prst="rect">
@@ -31873,13 +31912,13 @@
       </p:pic>
       <p:sp>
         <p:nvSpPr>
-          <p:cNvPr id="50" name="Text 38"/>
-          <p:cNvSpPr/>
-          <p:nvPr/>
-        </p:nvSpPr>
-        <p:spPr>
-          <a:xfrm>
-            <a:off x="6793992" y="5148072"/>
+          <p:cNvPr id="51" name="Text 39"/>
+          <p:cNvSpPr/>
+          <p:nvPr/>
+        </p:nvSpPr>
+        <p:spPr>
+          <a:xfrm>
+            <a:off x="6793992" y="5193792"/>
             <a:ext cx="4663440" cy="786384"/>
           </a:xfrm>
           <a:prstGeom prst="rect">
@@ -31912,30 +31951,30 @@
       </p:sp>
       <p:sp>
         <p:nvSpPr>
-          <p:cNvPr id="51" name="Text 39"/>
-          <p:cNvSpPr/>
-          <p:nvPr/>
-        </p:nvSpPr>
-        <p:spPr>
-          <a:xfrm>
-            <a:off x="594360" y="6172200"/>
-            <a:ext cx="11000232" cy="320040"/>
-          </a:xfrm>
-          <a:prstGeom prst="rect">
-            <a:avLst/>
-          </a:prstGeom>
-          <a:noFill/>
-          <a:ln/>
-        </p:spPr>
-        <p:txBody>
-          <a:bodyPr wrap="square" lIns="0" tIns="0" rIns="0" bIns="0" rtlCol="0" anchor="ctr"/>
-          <a:lstStyle/>
-          <a:p>
-            <a:pPr indent="0" marL="0">
-              <a:buNone/>
-            </a:pPr>
-            <a:r>
-              <a:rPr lang="en-US" sz="1200" i="1" dirty="0">
+          <p:cNvPr id="52" name="Text 40"/>
+          <p:cNvSpPr/>
+          <p:nvPr/>
+        </p:nvSpPr>
+        <p:spPr>
+          <a:xfrm>
+            <a:off x="594360" y="6144768"/>
+            <a:ext cx="11000232" cy="274320"/>
+          </a:xfrm>
+          <a:prstGeom prst="rect">
+            <a:avLst/>
+          </a:prstGeom>
+          <a:noFill/>
+          <a:ln/>
+        </p:spPr>
+        <p:txBody>
+          <a:bodyPr wrap="square" lIns="0" tIns="0" rIns="0" bIns="0" rtlCol="0" anchor="ctr"/>
+          <a:lstStyle/>
+          <a:p>
+            <a:pPr indent="0" marL="0">
+              <a:buNone/>
+            </a:pPr>
+            <a:r>
+              <a:rPr lang="en-US" sz="1150" i="1" dirty="0">
                 <a:solidFill>
                   <a:srgbClr val="C77F1A"/>
                 </a:solidFill>
@@ -31945,7 +31984,7 @@
               </a:rPr>
               <a:t>Cada antídoto vira uma cláusula do acordo de trabalho (DoR/DoD) — slide final do Bloco 5.</a:t>
             </a:r>
-            <a:endParaRPr lang="en-US" sz="1200" dirty="0"/>
+            <a:endParaRPr lang="en-US" sz="1150" dirty="0"/>
           </a:p>
         </p:txBody>
       </p:sp>

</xml_diff>